<commit_message>
2026/09/07 : upload syllabus, remove old stuffs
</commit_message>
<xml_diff>
--- a/syllabus/01_introduction/syllabus_01_intro.pptx
+++ b/syllabus/01_introduction/syllabus_01_intro.pptx
@@ -8404,7 +8404,7 @@
           <a:p>
             <a:fld id="{F3953782-D06E-4853-BE3C-64C197273937}" type="datetimeFigureOut">
               <a:rPr lang="fr-BE" smtClean="0"/>
-              <a:t>09-09-25</a:t>
+              <a:t>07-09-26</a:t>
             </a:fld>
             <a:endParaRPr lang="fr-BE"/>
           </a:p>
@@ -8486,6 +8486,22 @@
       </p:transition>
     </mc:Fallback>
   </mc:AlternateContent>
+  <p:extLst>
+    <p:ext uri="{DCECCB84-F9BA-43D5-87BE-67443E8EF086}">
+      <p15:sldGuideLst xmlns:p15="http://schemas.microsoft.com/office/powerpoint/2012/main">
+        <p15:guide id="1" orient="horz" pos="2160" userDrawn="1">
+          <p15:clr>
+            <a:srgbClr val="FBAE40"/>
+          </p15:clr>
+        </p15:guide>
+        <p15:guide id="2" pos="3840" userDrawn="1">
+          <p15:clr>
+            <a:srgbClr val="FBAE40"/>
+          </p15:clr>
+        </p15:guide>
+      </p15:sldGuideLst>
+    </p:ext>
+  </p:extLst>
 </p:sldLayout>
 </file>
 
@@ -10746,7 +10762,7 @@
           <a:p>
             <a:fld id="{F3953782-D06E-4853-BE3C-64C197273937}" type="datetimeFigureOut">
               <a:rPr lang="fr-BE" smtClean="0"/>
-              <a:t>09-09-25</a:t>
+              <a:t>07-09-26</a:t>
             </a:fld>
             <a:endParaRPr lang="fr-BE"/>
           </a:p>
@@ -11067,7 +11083,7 @@
           <a:p>
             <a:fld id="{F3953782-D06E-4853-BE3C-64C197273937}" type="datetimeFigureOut">
               <a:rPr lang="fr-BE" smtClean="0"/>
-              <a:t>09-09-25</a:t>
+              <a:t>07-09-26</a:t>
             </a:fld>
             <a:endParaRPr lang="fr-BE"/>
           </a:p>
@@ -11270,7 +11286,7 @@
           <a:p>
             <a:fld id="{F3953782-D06E-4853-BE3C-64C197273937}" type="datetimeFigureOut">
               <a:rPr lang="fr-BE" smtClean="0"/>
-              <a:t>09-09-25</a:t>
+              <a:t>07-09-26</a:t>
             </a:fld>
             <a:endParaRPr lang="fr-BE"/>
           </a:p>
@@ -11533,7 +11549,7 @@
           <a:p>
             <a:fld id="{F3953782-D06E-4853-BE3C-64C197273937}" type="datetimeFigureOut">
               <a:rPr lang="fr-BE" smtClean="0"/>
-              <a:t>09-09-25</a:t>
+              <a:t>07-09-26</a:t>
             </a:fld>
             <a:endParaRPr lang="fr-BE"/>
           </a:p>
@@ -11930,7 +11946,7 @@
           <a:p>
             <a:fld id="{F3953782-D06E-4853-BE3C-64C197273937}" type="datetimeFigureOut">
               <a:rPr lang="fr-BE" smtClean="0"/>
-              <a:t>09-09-25</a:t>
+              <a:t>07-09-26</a:t>
             </a:fld>
             <a:endParaRPr lang="fr-BE"/>
           </a:p>
@@ -12079,7 +12095,7 @@
           <a:p>
             <a:fld id="{F3953782-D06E-4853-BE3C-64C197273937}" type="datetimeFigureOut">
               <a:rPr lang="fr-BE" smtClean="0"/>
-              <a:t>09-09-25</a:t>
+              <a:t>07-09-26</a:t>
             </a:fld>
             <a:endParaRPr lang="fr-BE"/>
           </a:p>
@@ -12428,7 +12444,7 @@
           <a:p>
             <a:fld id="{F3953782-D06E-4853-BE3C-64C197273937}" type="datetimeFigureOut">
               <a:rPr lang="fr-BE" smtClean="0"/>
-              <a:t>09-09-25</a:t>
+              <a:t>07-09-26</a:t>
             </a:fld>
             <a:endParaRPr lang="fr-BE"/>
           </a:p>
@@ -12636,36 +12652,6 @@
           </a:p>
         </p:txBody>
       </p:sp>
-      <p:pic>
-        <p:nvPicPr>
-          <p:cNvPr id="8" name="Picture 7"/>
-          <p:cNvPicPr>
-            <a:picLocks noChangeAspect="1"/>
-          </p:cNvPicPr>
-          <p:nvPr/>
-        </p:nvPicPr>
-        <p:blipFill>
-          <a:blip r:embed="rId14">
-            <a:extLst>
-              <a:ext uri="{28A0092B-C50C-407E-A947-70E740481C1C}">
-                <a14:useLocalDpi xmlns:a14="http://schemas.microsoft.com/office/drawing/2010/main" val="0"/>
-              </a:ext>
-            </a:extLst>
-          </a:blip>
-          <a:stretch>
-            <a:fillRect/>
-          </a:stretch>
-        </p:blipFill>
-        <p:spPr>
-          <a:xfrm>
-            <a:off x="10830515" y="5719725"/>
-            <a:ext cx="1046571" cy="914479"/>
-          </a:xfrm>
-          <a:prstGeom prst="rect">
-            <a:avLst/>
-          </a:prstGeom>
-        </p:spPr>
-      </p:pic>
       <p:sp>
         <p:nvSpPr>
           <p:cNvPr id="4" name="Espace réservé du numéro de diapositive 3">
@@ -12754,7 +12740,7 @@
           <a:p>
             <a:fld id="{F3953782-D06E-4853-BE3C-64C197273937}" type="datetimeFigureOut">
               <a:rPr lang="fr-BE" smtClean="0"/>
-              <a:t>09-09-25</a:t>
+              <a:t>07-09-26</a:t>
             </a:fld>
             <a:endParaRPr lang="fr-BE"/>
           </a:p>
@@ -13199,6 +13185,22 @@
       </a:lvl9pPr>
     </p:otherStyle>
   </p:txStyles>
+  <p:extLst>
+    <p:ext uri="{27BBF7A9-308A-43DC-89C8-2F10F3537804}">
+      <p15:sldGuideLst xmlns:p15="http://schemas.microsoft.com/office/powerpoint/2012/main">
+        <p15:guide id="1" orient="horz" pos="2160" userDrawn="1">
+          <p15:clr>
+            <a:srgbClr val="F26B43"/>
+          </p15:clr>
+        </p15:guide>
+        <p15:guide id="2" pos="3840" userDrawn="1">
+          <p15:clr>
+            <a:srgbClr val="F26B43"/>
+          </p15:clr>
+        </p15:guide>
+      </p15:sldGuideLst>
+    </p:ext>
+  </p:extLst>
 </p:sldMaster>
 </file>
 
@@ -18801,6 +18803,10 @@
           </p:nvPr>
         </p:nvSpPr>
         <p:spPr>
+          <a:xfrm>
+            <a:off x="839788" y="365125"/>
+            <a:ext cx="10515600" cy="1325563"/>
+          </a:xfrm>
           <a:noFill/>
           <a:ln>
             <a:noFill/>
@@ -18831,6 +18837,10 @@
           </p:nvPr>
         </p:nvSpPr>
         <p:spPr>
+          <a:xfrm>
+            <a:off x="839788" y="1681163"/>
+            <a:ext cx="3420000" cy="676143"/>
+          </a:xfrm>
           <a:noFill/>
           <a:ln>
             <a:noFill/>
@@ -18866,7 +18876,12 @@
             <p:ph type="body" idx="2"/>
           </p:nvPr>
         </p:nvSpPr>
-        <p:spPr/>
+        <p:spPr>
+          <a:xfrm>
+            <a:off x="839788" y="2353338"/>
+            <a:ext cx="3419999" cy="3836325"/>
+          </a:xfrm>
+        </p:spPr>
         <p:txBody>
           <a:bodyPr>
             <a:normAutofit/>
@@ -18877,7 +18892,11 @@
               <a:buNone/>
             </a:pPr>
             <a:r>
-              <a:rPr lang="fr-BE" sz="2400"/>
+              <a:rPr lang="fr-BE" sz="2400">
+                <a:solidFill>
+                  <a:schemeClr val="accent2"/>
+                </a:solidFill>
+              </a:rPr>
               <a:t>01. Introduction au web</a:t>
             </a:r>
           </a:p>
@@ -18932,7 +18951,12 @@
             <p:ph type="body" idx="3"/>
           </p:nvPr>
         </p:nvSpPr>
-        <p:spPr/>
+        <p:spPr>
+          <a:xfrm>
+            <a:off x="4394864" y="1677195"/>
+            <a:ext cx="3420000" cy="676143"/>
+          </a:xfrm>
+        </p:spPr>
         <p:txBody>
           <a:bodyPr anchor="t"/>
           <a:lstStyle/>
@@ -18963,8 +18987,8 @@
         </p:nvSpPr>
         <p:spPr>
           <a:xfrm>
-            <a:off x="4105275" y="2501107"/>
-            <a:ext cx="3709587" cy="3684588"/>
+            <a:off x="4394863" y="2357306"/>
+            <a:ext cx="3419999" cy="3828389"/>
           </a:xfrm>
         </p:spPr>
         <p:txBody>
@@ -19053,7 +19077,12 @@
             <p:ph type="body" idx="10"/>
           </p:nvPr>
         </p:nvSpPr>
-        <p:spPr/>
+        <p:spPr>
+          <a:xfrm>
+            <a:off x="7949940" y="1690688"/>
+            <a:ext cx="3420000" cy="662650"/>
+          </a:xfrm>
+        </p:spPr>
         <p:txBody>
           <a:bodyPr anchor="t"/>
           <a:lstStyle/>
@@ -19081,10 +19110,15 @@
             <p:ph type="body" idx="11"/>
           </p:nvPr>
         </p:nvSpPr>
-        <p:spPr/>
+        <p:spPr>
+          <a:xfrm>
+            <a:off x="7949937" y="2377806"/>
+            <a:ext cx="3433923" cy="3836325"/>
+          </a:xfrm>
+        </p:spPr>
         <p:txBody>
           <a:bodyPr>
-            <a:normAutofit/>
+            <a:normAutofit lnSpcReduction="10000"/>
           </a:bodyPr>
           <a:lstStyle/>
           <a:p>
@@ -19133,12 +19167,24 @@
             </a:r>
           </a:p>
           <a:p>
+            <a:pPr marL="114300" lvl="0" indent="0">
+              <a:buNone/>
+            </a:pPr>
+            <a:endParaRPr lang="fr-BE" sz="2400"/>
+          </a:p>
+          <a:p>
+            <a:pPr marL="114300" lvl="0" indent="0">
+              <a:buNone/>
+            </a:pPr>
+            <a:endParaRPr lang="fr-BE" sz="2400"/>
+          </a:p>
+          <a:p>
             <a:pPr marL="114300" indent="0">
               <a:buNone/>
             </a:pPr>
             <a:r>
               <a:rPr lang="fr-BE" sz="2400"/>
-              <a:t>27. Requête asynchrone</a:t>
+              <a:t>31. Requête asynchrone</a:t>
             </a:r>
           </a:p>
           <a:p>
@@ -19146,6 +19192,272 @@
               <a:buNone/>
             </a:pPr>
             <a:endParaRPr lang="fr-BE" sz="2400"/>
+          </a:p>
+        </p:txBody>
+      </p:sp>
+      <p:sp>
+        <p:nvSpPr>
+          <p:cNvPr id="5" name="Espace réservé du texte 9">
+            <a:extLst>
+              <a:ext uri="{FF2B5EF4-FFF2-40B4-BE49-F238E27FC236}">
+                <a16:creationId xmlns:a16="http://schemas.microsoft.com/office/drawing/2014/main" id="{F7F80AB2-1A54-F3C7-63AD-635689291298}"/>
+              </a:ext>
+            </a:extLst>
+          </p:cNvPr>
+          <p:cNvSpPr txBox="1">
+            <a:spLocks/>
+          </p:cNvSpPr>
+          <p:nvPr/>
+        </p:nvSpPr>
+        <p:spPr>
+          <a:xfrm>
+            <a:off x="7932738" y="5026572"/>
+            <a:ext cx="3751261" cy="823912"/>
+          </a:xfrm>
+          <a:prstGeom prst="rect">
+            <a:avLst/>
+          </a:prstGeom>
+          <a:noFill/>
+          <a:ln>
+            <a:noFill/>
+          </a:ln>
+        </p:spPr>
+        <p:txBody>
+          <a:bodyPr spcFirstLastPara="1" vert="horz" wrap="square" lIns="91425" tIns="45700" rIns="91425" bIns="45700" rtlCol="0" anchor="t" anchorCtr="0">
+            <a:normAutofit/>
+          </a:bodyPr>
+          <a:lstStyle>
+            <a:lvl1pPr marL="457200" lvl="0" indent="-228600" algn="l" defTabSz="914377" rtl="0" eaLnBrk="1" latinLnBrk="0" hangingPunct="1">
+              <a:lnSpc>
+                <a:spcPct val="90000"/>
+              </a:lnSpc>
+              <a:spcBef>
+                <a:spcPts val="1000"/>
+              </a:spcBef>
+              <a:spcAft>
+                <a:spcPts val="0"/>
+              </a:spcAft>
+              <a:buClr>
+                <a:schemeClr val="dk1"/>
+              </a:buClr>
+              <a:buSzPts val="2400"/>
+              <a:buFont typeface="Wingdings" panose="05000000000000000000" pitchFamily="2" charset="2"/>
+              <a:buNone/>
+              <a:defRPr sz="2400" b="1" kern="1200">
+                <a:solidFill>
+                  <a:schemeClr val="tx1"/>
+                </a:solidFill>
+                <a:latin typeface="+mn-lt"/>
+                <a:ea typeface="+mn-ea"/>
+                <a:cs typeface="+mn-cs"/>
+              </a:defRPr>
+            </a:lvl1pPr>
+            <a:lvl2pPr marL="914400" lvl="1" indent="-228600" algn="l" defTabSz="914377" rtl="0" eaLnBrk="1" latinLnBrk="0" hangingPunct="1">
+              <a:lnSpc>
+                <a:spcPct val="90000"/>
+              </a:lnSpc>
+              <a:spcBef>
+                <a:spcPts val="500"/>
+              </a:spcBef>
+              <a:spcAft>
+                <a:spcPts val="0"/>
+              </a:spcAft>
+              <a:buClr>
+                <a:schemeClr val="dk1"/>
+              </a:buClr>
+              <a:buSzPts val="2000"/>
+              <a:buFont typeface="Wingdings" panose="05000000000000000000" pitchFamily="2" charset="2"/>
+              <a:buNone/>
+              <a:defRPr sz="2000" b="1" kern="1200">
+                <a:solidFill>
+                  <a:schemeClr val="tx1"/>
+                </a:solidFill>
+                <a:latin typeface="+mn-lt"/>
+                <a:ea typeface="+mn-ea"/>
+                <a:cs typeface="+mn-cs"/>
+              </a:defRPr>
+            </a:lvl2pPr>
+            <a:lvl3pPr marL="1371600" lvl="2" indent="-228600" algn="l" defTabSz="914377" rtl="0" eaLnBrk="1" latinLnBrk="0" hangingPunct="1">
+              <a:lnSpc>
+                <a:spcPct val="90000"/>
+              </a:lnSpc>
+              <a:spcBef>
+                <a:spcPts val="500"/>
+              </a:spcBef>
+              <a:spcAft>
+                <a:spcPts val="0"/>
+              </a:spcAft>
+              <a:buClr>
+                <a:schemeClr val="dk1"/>
+              </a:buClr>
+              <a:buSzPts val="1800"/>
+              <a:buFont typeface="Wingdings" panose="05000000000000000000" pitchFamily="2" charset="2"/>
+              <a:buNone/>
+              <a:defRPr sz="1800" b="1" kern="1200">
+                <a:solidFill>
+                  <a:schemeClr val="tx1"/>
+                </a:solidFill>
+                <a:latin typeface="+mn-lt"/>
+                <a:ea typeface="+mn-ea"/>
+                <a:cs typeface="+mn-cs"/>
+              </a:defRPr>
+            </a:lvl3pPr>
+            <a:lvl4pPr marL="1828800" lvl="3" indent="-228600" algn="l" defTabSz="914377" rtl="0" eaLnBrk="1" latinLnBrk="0" hangingPunct="1">
+              <a:lnSpc>
+                <a:spcPct val="90000"/>
+              </a:lnSpc>
+              <a:spcBef>
+                <a:spcPts val="500"/>
+              </a:spcBef>
+              <a:spcAft>
+                <a:spcPts val="0"/>
+              </a:spcAft>
+              <a:buClr>
+                <a:schemeClr val="dk1"/>
+              </a:buClr>
+              <a:buSzPts val="1600"/>
+              <a:buFont typeface="Wingdings" panose="05000000000000000000" pitchFamily="2" charset="2"/>
+              <a:buNone/>
+              <a:defRPr sz="1600" b="1" kern="1200">
+                <a:solidFill>
+                  <a:schemeClr val="tx1"/>
+                </a:solidFill>
+                <a:latin typeface="+mn-lt"/>
+                <a:ea typeface="+mn-ea"/>
+                <a:cs typeface="+mn-cs"/>
+              </a:defRPr>
+            </a:lvl4pPr>
+            <a:lvl5pPr marL="2286000" lvl="4" indent="-228600" algn="l" defTabSz="914377" rtl="0" eaLnBrk="1" latinLnBrk="0" hangingPunct="1">
+              <a:lnSpc>
+                <a:spcPct val="90000"/>
+              </a:lnSpc>
+              <a:spcBef>
+                <a:spcPts val="500"/>
+              </a:spcBef>
+              <a:spcAft>
+                <a:spcPts val="0"/>
+              </a:spcAft>
+              <a:buClr>
+                <a:schemeClr val="dk1"/>
+              </a:buClr>
+              <a:buSzPts val="1600"/>
+              <a:buFont typeface="Wingdings" panose="05000000000000000000" pitchFamily="2" charset="2"/>
+              <a:buNone/>
+              <a:defRPr sz="1600" b="1" kern="1200">
+                <a:solidFill>
+                  <a:schemeClr val="tx1"/>
+                </a:solidFill>
+                <a:latin typeface="+mn-lt"/>
+                <a:ea typeface="+mn-ea"/>
+                <a:cs typeface="+mn-cs"/>
+              </a:defRPr>
+            </a:lvl5pPr>
+            <a:lvl6pPr marL="2743200" lvl="5" indent="-228600" algn="l" defTabSz="914377" rtl="0" eaLnBrk="1" latinLnBrk="0" hangingPunct="1">
+              <a:lnSpc>
+                <a:spcPct val="90000"/>
+              </a:lnSpc>
+              <a:spcBef>
+                <a:spcPts val="500"/>
+              </a:spcBef>
+              <a:spcAft>
+                <a:spcPts val="0"/>
+              </a:spcAft>
+              <a:buClr>
+                <a:schemeClr val="dk1"/>
+              </a:buClr>
+              <a:buSzPts val="1600"/>
+              <a:buFont typeface="Arial" panose="020B0604020202020204" pitchFamily="34" charset="0"/>
+              <a:buNone/>
+              <a:defRPr sz="1600" b="1" kern="1200">
+                <a:solidFill>
+                  <a:schemeClr val="tx1"/>
+                </a:solidFill>
+                <a:latin typeface="+mn-lt"/>
+                <a:ea typeface="+mn-ea"/>
+                <a:cs typeface="+mn-cs"/>
+              </a:defRPr>
+            </a:lvl6pPr>
+            <a:lvl7pPr marL="3200400" lvl="6" indent="-228600" algn="l" defTabSz="914377" rtl="0" eaLnBrk="1" latinLnBrk="0" hangingPunct="1">
+              <a:lnSpc>
+                <a:spcPct val="90000"/>
+              </a:lnSpc>
+              <a:spcBef>
+                <a:spcPts val="500"/>
+              </a:spcBef>
+              <a:spcAft>
+                <a:spcPts val="0"/>
+              </a:spcAft>
+              <a:buClr>
+                <a:schemeClr val="dk1"/>
+              </a:buClr>
+              <a:buSzPts val="1600"/>
+              <a:buFont typeface="Arial" panose="020B0604020202020204" pitchFamily="34" charset="0"/>
+              <a:buNone/>
+              <a:defRPr sz="1600" b="1" kern="1200">
+                <a:solidFill>
+                  <a:schemeClr val="tx1"/>
+                </a:solidFill>
+                <a:latin typeface="+mn-lt"/>
+                <a:ea typeface="+mn-ea"/>
+                <a:cs typeface="+mn-cs"/>
+              </a:defRPr>
+            </a:lvl7pPr>
+            <a:lvl8pPr marL="3657600" lvl="7" indent="-228600" algn="l" defTabSz="914377" rtl="0" eaLnBrk="1" latinLnBrk="0" hangingPunct="1">
+              <a:lnSpc>
+                <a:spcPct val="90000"/>
+              </a:lnSpc>
+              <a:spcBef>
+                <a:spcPts val="500"/>
+              </a:spcBef>
+              <a:spcAft>
+                <a:spcPts val="0"/>
+              </a:spcAft>
+              <a:buClr>
+                <a:schemeClr val="dk1"/>
+              </a:buClr>
+              <a:buSzPts val="1600"/>
+              <a:buFont typeface="Arial" panose="020B0604020202020204" pitchFamily="34" charset="0"/>
+              <a:buNone/>
+              <a:defRPr sz="1600" b="1" kern="1200">
+                <a:solidFill>
+                  <a:schemeClr val="tx1"/>
+                </a:solidFill>
+                <a:latin typeface="+mn-lt"/>
+                <a:ea typeface="+mn-ea"/>
+                <a:cs typeface="+mn-cs"/>
+              </a:defRPr>
+            </a:lvl8pPr>
+            <a:lvl9pPr marL="4114800" lvl="8" indent="-228600" algn="l" defTabSz="914377" rtl="0" eaLnBrk="1" latinLnBrk="0" hangingPunct="1">
+              <a:lnSpc>
+                <a:spcPct val="90000"/>
+              </a:lnSpc>
+              <a:spcBef>
+                <a:spcPts val="500"/>
+              </a:spcBef>
+              <a:spcAft>
+                <a:spcPts val="0"/>
+              </a:spcAft>
+              <a:buClr>
+                <a:schemeClr val="dk1"/>
+              </a:buClr>
+              <a:buSzPts val="1600"/>
+              <a:buFont typeface="Arial" panose="020B0604020202020204" pitchFamily="34" charset="0"/>
+              <a:buNone/>
+              <a:defRPr sz="1600" b="1" kern="1200">
+                <a:solidFill>
+                  <a:schemeClr val="tx1"/>
+                </a:solidFill>
+                <a:latin typeface="+mn-lt"/>
+                <a:ea typeface="+mn-ea"/>
+                <a:cs typeface="+mn-cs"/>
+              </a:defRPr>
+            </a:lvl9pPr>
+          </a:lstStyle>
+          <a:p>
+            <a:r>
+              <a:rPr lang="fr-BE"/>
+              <a:t>Single Page Application</a:t>
+            </a:r>
           </a:p>
         </p:txBody>
       </p:sp>

</xml_diff>